<commit_message>
Tamil Nadu: turnout on the election roll, women from the January 2025 roll by seat, exact claims and objections
- The roll of 6 April 2026 (the CEO's, by seat and sex) is the roll the
  election was held on; turnout is now votes over it (86.0%, was 87.0% on the
  final roll), and the living names removed exceed the margin at turnout in
  168 seats (was 169). Corrections entry added.
- The CEO's final roll of 6 January 2025 by seat and sex: the fall from it to
  the draft, by sex, always called the fall. Women 51.1% of it against 51.0%
  of the roll, above their share in 145 of 234 seats, Vedaranyam 60.4%.
  Translated into all five languages.
- final.csv carries the CEO's exact counts after the draft (27,53,796 added,
  4,23,172 deleted), which add up to the final roll.
- Tamil Nadu report and deck rebuilt.

Co-Authored-By: Claude Opus 5.5 <noreply@anthropic.com>
Claude-Session: https://claude.ai/code/session_012JjD5mhtvLxzAXoZHMZYE5
</commit_message>
<xml_diff>
--- a/reports/tamil-nadu-sir-2026-deck.pptx
+++ b/reports/tamil-nadu-sir-2026-deck.pptx
@@ -7702,7 +7702,7 @@
                 <a:ea typeface="Cambria" pitchFamily="34" charset="-122"/>
                 <a:cs typeface="Cambria" pitchFamily="34" charset="-120"/>
               </a:rPr>
-              <a:t>Counting only the living removed at each seat's turnout, they outnumber the margin in 169 seats</a:t>
+              <a:t>Counting only the living removed at each seat's turnout, they outnumber the margin in 168 seats</a:t>
             </a:r>
             <a:endParaRPr lang="en-US" sz="2700" dirty="0"/>
           </a:p>
@@ -8890,7 +8890,7 @@
                 <a:ea typeface="Cambria" pitchFamily="34" charset="-122"/>
                 <a:cs typeface="Cambria" pitchFamily="34" charset="-120"/>
               </a:rPr>
-              <a:t>169 of 234</a:t>
+              <a:t>168 of 234</a:t>
             </a:r>
             <a:endParaRPr lang="en-US" sz="2800" dirty="0"/>
           </a:p>
@@ -8975,7 +8975,7 @@
                 <a:ea typeface="Calibri" pitchFamily="34" charset="-122"/>
                 <a:cs typeface="Calibri" pitchFamily="34" charset="-120"/>
               </a:rPr>
-              <a:t>In the other 65 seats, the runner-up could not have won even if every living person removed had voted for the runner-up at the seat's turnout. Even the narrowest count assumes all of them would have, which nobody can know.</a:t>
+              <a:t>In the other 66 seats, the runner-up could not have won even if every living person removed had voted for the runner-up at the seat's turnout. Even the narrowest count assumes all of them would have, which nobody can know.</a:t>
             </a:r>
             <a:endParaRPr lang="en-US" sz="1600" dirty="0"/>
           </a:p>
@@ -21096,7 +21096,7 @@
                 <a:ea typeface="Calibri" pitchFamily="34" charset="-122"/>
                 <a:cs typeface="Calibri" pitchFamily="34" charset="-120"/>
               </a:rPr>
-              <a:t>In 211 of the 234 constituencies, more names were left off than the 2026 winning margin, large enough to decide the seat. Counting only the removed not entered as dead, at each seat's turnout, the number is 169.</a:t>
+              <a:t>In 211 of the 234 constituencies, more names were left off than the 2026 winning margin, large enough to decide the seat. Counting only the removed not entered as dead, at each seat's turnout, the number is 168.</a:t>
             </a:r>
             <a:endParaRPr lang="en-US" sz="1600" dirty="0"/>
           </a:p>

</xml_diff>